<commit_message>
chore: remove generated artifacts from repository
</commit_message>
<xml_diff>
--- a/app/artifacts/decks/Sales_Analysis_2026-09-05.pptx
+++ b/app/artifacts/decks/Sales_Analysis_2026-09-05.pptx
@@ -3118,7 +3118,7 @@
             <a:pPr>
               <a:defRPr sz="2400" b="1">
                 <a:solidFill>
-                  <a:srgbClr val="1A365D"/>
+                  <a:srgbClr val="1B5E20"/>
                 </a:solidFill>
               </a:defRPr>
             </a:pPr>
@@ -3153,12 +3153,12 @@
             <a:pPr>
               <a:defRPr sz="1800" b="1">
                 <a:solidFill>
-                  <a:srgbClr val="2B6CB0"/>
+                  <a:srgbClr val="2E7D32"/>
                 </a:solidFill>
               </a:defRPr>
             </a:pPr>
             <a:r>
-              <a:t>🏪 Store Operations Report for 2026-09-05</a:t>
+              <a:t>🏪 GreenBasket Supermart — Operations Report for 2026-09-05</a:t>
             </a:r>
           </a:p>
           <a:p>
@@ -3281,7 +3281,7 @@
             <a:pPr>
               <a:defRPr sz="2400" b="1">
                 <a:solidFill>
-                  <a:srgbClr val="1A365D"/>
+                  <a:srgbClr val="1B5E20"/>
                 </a:solidFill>
               </a:defRPr>
             </a:pPr>
@@ -3417,7 +3417,7 @@
             <a:pPr>
               <a:defRPr sz="2400" b="1">
                 <a:solidFill>
-                  <a:srgbClr val="1A365D"/>
+                  <a:srgbClr val="1B5E20"/>
                 </a:solidFill>
               </a:defRPr>
             </a:pPr>
@@ -3508,7 +3508,7 @@
             <a:pPr>
               <a:defRPr sz="2400" b="1">
                 <a:solidFill>
-                  <a:srgbClr val="1A365D"/>
+                  <a:srgbClr val="1B5E20"/>
                 </a:solidFill>
               </a:defRPr>
             </a:pPr>
@@ -3543,7 +3543,7 @@
             <a:pPr>
               <a:defRPr sz="1600">
                 <a:solidFill>
-                  <a:srgbClr val="38A169"/>
+                  <a:srgbClr val="43A047"/>
                 </a:solidFill>
               </a:defRPr>
             </a:pPr>
@@ -3596,7 +3596,7 @@
             <a:pPr>
               <a:defRPr sz="2400" b="1">
                 <a:solidFill>
-                  <a:srgbClr val="1A365D"/>
+                  <a:srgbClr val="1B5E20"/>
                 </a:solidFill>
               </a:defRPr>
             </a:pPr>
@@ -3634,7 +3634,7 @@
               </a:spcAft>
               <a:defRPr sz="1800" b="1">
                 <a:solidFill>
-                  <a:srgbClr val="2B6CB0"/>
+                  <a:srgbClr val="2E7D32"/>
                 </a:solidFill>
               </a:defRPr>
             </a:pPr>
@@ -3699,7 +3699,7 @@
             <a:pPr>
               <a:defRPr sz="2400" b="1">
                 <a:solidFill>
-                  <a:srgbClr val="1A365D"/>
+                  <a:srgbClr val="1B5E20"/>
                 </a:solidFill>
               </a:defRPr>
             </a:pPr>

</xml_diff>